<commit_message>
Slides: sessions 11 and 24; others in progress
Co-Authored-By: Claude Opus 5.5 <noreply@anthropic.com>
Claude-Session: https://claude.ai/code/session_01XkzKv8pUGMF9AsqSCMpnBq
</commit_message>
<xml_diff>
--- a/slides/decks/s21-aml.pptx
+++ b/slides/decks/s21-aml.pptx
@@ -135,13 +135,13 @@
   <p:extLst>
     <p:ext uri="{521415D9-36F7-43E2-AB2F-B90AF26B5E84}">
       <p14:sectionLst xmlns:p14="http://schemas.microsoft.com/office/powerpoint/2010/main">
-        <p14:section name="Opening" id="{d6bd5f17-fc60-ff4b-6252-a728b9fcb1aa}">
+        <p14:section name="Opening" id="{9579f7b9-227b-1987-2657-67a47ee59c24}">
           <p14:sldIdLst>
             <p14:sldId id="256"/>
             <p14:sldId id="257"/>
           </p14:sldIdLst>
         </p14:section>
-        <p14:section name="AML in CR1" id="{bbd75bda-4414-dfd8-275e-8273b5e9cee0}">
+        <p14:section name="AML in CR1" id="{6f4eaae4-3d81-f0d5-477b-3c57d0791348}">
           <p14:sldIdLst>
             <p14:sldId id="258"/>
             <p14:sldId id="259"/>
@@ -152,14 +152,14 @@
             <p14:sldId id="264"/>
           </p14:sldIdLst>
         </p14:section>
-        <p14:section name="Advanced AML" id="{a935eb54-2f32-f73d-7f5b-169c5cdbc617}">
+        <p14:section name="Advanced AML" id="{c34f1e5e-eca2-2b12-2e60-7094aa90290e}">
           <p14:sldIdLst>
             <p14:sldId id="265"/>
             <p14:sldId id="266"/>
             <p14:sldId id="267"/>
           </p14:sldIdLst>
         </p14:section>
-        <p14:section name="APL and children" id="{b59f6a3e-0ee0-d309-ce30-b84e9f2796a4}">
+        <p14:section name="APL and children" id="{0ce66ce9-429c-d863-c010-0948269267dc}">
           <p14:sldIdLst>
             <p14:sldId id="268"/>
             <p14:sldId id="269"/>
@@ -167,7 +167,7 @@
             <p14:sldId id="271"/>
           </p14:sldIdLst>
         </p14:section>
-        <p14:section name="Board questions" id="{3074b02a-2297-d418-a1f2-c9758b0ff1d0}">
+        <p14:section name="Board questions" id="{64942ada-555e-4326-c9c5-29e49796fc49}">
           <p14:sldIdLst>
             <p14:sldId id="272"/>
             <p14:sldId id="273"/>
@@ -177,7 +177,7 @@
             <p14:sldId id="277"/>
           </p14:sldIdLst>
         </p14:section>
-        <p14:section name="References" id="{f38e5346-18fa-5cc9-2b4e-ab5040460314}">
+        <p14:section name="References" id="{21e30bfe-e9b1-6eba-2d22-63f55b1ad021}">
           <p14:sldIdLst>
             <p14:sldId id="278"/>
             <p14:sldId id="279"/>
@@ -185,7 +185,7 @@
             <p14:sldId id="281"/>
           </p14:sldIdLst>
         </p14:section>
-        <p14:section name="Backup" id="{f50b6650-aebe-770b-2530-040ec10add0d}">
+        <p14:section name="Backup" id="{34358fe2-e17a-1be5-ca48-b47d292c64fc}">
           <p14:sldIdLst>
             <p14:sldId id="282"/>
             <p14:sldId id="283"/>
@@ -11050,14 +11050,14 @@
                         <a:buNone/>
                       </a:pPr>
                       <a:r>
-                        <a:rPr lang="en-US" sz="1500" b="1" dirty="0">
+                        <a:rPr lang="en-US" sz="1600" b="1" dirty="0">
                           <a:solidFill>
                             <a:schemeClr val="tx1"/>
                           </a:solidFill>
                         </a:rPr>
                         <a:t>Topic</a:t>
                       </a:r>
-                      <a:endParaRPr lang="en-US" sz="1500" dirty="0"/>
+                      <a:endParaRPr lang="en-US" sz="1600" dirty="0"/>
                     </a:p>
                   </a:txBody>
                   <a:tcPr marL="25400" marR="101600" marT="63500" marB="63500" anchor="ctr">
@@ -11096,14 +11096,14 @@
                         <a:buNone/>
                       </a:pPr>
                       <a:r>
-                        <a:rPr lang="en-US" sz="1500" b="1" dirty="0">
+                        <a:rPr lang="en-US" sz="1600" b="1" dirty="0">
                           <a:solidFill>
                             <a:schemeClr val="tx1"/>
                           </a:solidFill>
                         </a:rPr>
                         <a:t>Adults (Ch. 70)</a:t>
                       </a:r>
-                      <a:endParaRPr lang="en-US" sz="1500" dirty="0"/>
+                      <a:endParaRPr lang="en-US" sz="1600" dirty="0"/>
                     </a:p>
                   </a:txBody>
                   <a:tcPr marL="25400" marR="101600" marT="63500" marB="63500" anchor="ctr">
@@ -11142,14 +11142,14 @@
                         <a:buNone/>
                       </a:pPr>
                       <a:r>
-                        <a:rPr lang="en-US" sz="1500" b="1" dirty="0">
+                        <a:rPr lang="en-US" sz="1600" b="1" dirty="0">
                           <a:solidFill>
                             <a:schemeClr val="tx1"/>
                           </a:solidFill>
                         </a:rPr>
                         <a:t>Children (Ch. 71)</a:t>
                       </a:r>
-                      <a:endParaRPr lang="en-US" sz="1500" dirty="0"/>
+                      <a:endParaRPr lang="en-US" sz="1600" dirty="0"/>
                     </a:p>
                   </a:txBody>
                   <a:tcPr marL="25400" marR="101600" marT="63500" marB="63500" anchor="ctr">
@@ -11190,14 +11190,14 @@
                         <a:buNone/>
                       </a:pPr>
                       <a:r>
-                        <a:rPr lang="en-US" sz="1500" dirty="0">
+                        <a:rPr lang="en-US" sz="1600" dirty="0">
                           <a:solidFill>
                             <a:schemeClr val="tx1"/>
                           </a:solidFill>
                         </a:rPr>
                         <a:t>CR1 indication</a:t>
                       </a:r>
-                      <a:endParaRPr lang="en-US" sz="1500" dirty="0"/>
+                      <a:endParaRPr lang="en-US" sz="1600" dirty="0"/>
                     </a:p>
                   </a:txBody>
                   <a:tcPr marL="25400" marR="101600" marT="63500" marB="63500" anchor="ctr">
@@ -11230,14 +11230,14 @@
                         <a:buNone/>
                       </a:pPr>
                       <a:r>
-                        <a:rPr lang="en-US" sz="1500" dirty="0">
+                        <a:rPr lang="en-US" sz="1600" dirty="0">
                           <a:solidFill>
                             <a:schemeClr val="tx1"/>
                           </a:solidFill>
                         </a:rPr>
                         <a:t>ELN 2022 risk + MRD + TRM</a:t>
                       </a:r>
-                      <a:endParaRPr lang="en-US" sz="1500" dirty="0"/>
+                      <a:endParaRPr lang="en-US" sz="1600" dirty="0"/>
                     </a:p>
                   </a:txBody>
                   <a:tcPr marL="25400" marR="101600" marT="63500" marB="63500" anchor="ctr">
@@ -11270,14 +11270,14 @@
                         <a:buNone/>
                       </a:pPr>
                       <a:r>
-                        <a:rPr lang="en-US" sz="1500" dirty="0">
+                        <a:rPr lang="en-US" sz="1600" dirty="0">
                           <a:solidFill>
                             <a:schemeClr val="tx1"/>
                           </a:solidFill>
                         </a:rPr>
                         <a:t>Poor-risk genetics (about 30%) ± early MRD</a:t>
                       </a:r>
-                      <a:endParaRPr lang="en-US" sz="1500" dirty="0"/>
+                      <a:endParaRPr lang="en-US" sz="1600" dirty="0"/>
                     </a:p>
                   </a:txBody>
                   <a:tcPr marL="25400" marR="101600" marT="63500" marB="63500" anchor="ctr">
@@ -11312,14 +11312,14 @@
                         <a:buNone/>
                       </a:pPr>
                       <a:r>
-                        <a:rPr lang="en-US" sz="1500" dirty="0">
+                        <a:rPr lang="en-US" sz="1600" dirty="0">
                           <a:solidFill>
                             <a:schemeClr val="tx1"/>
                           </a:solidFill>
                         </a:rPr>
                         <a:t>No HCT in CR1</a:t>
                       </a:r>
-                      <a:endParaRPr lang="en-US" sz="1500" dirty="0"/>
+                      <a:endParaRPr lang="en-US" sz="1600" dirty="0"/>
                     </a:p>
                   </a:txBody>
                   <a:tcPr marL="25400" marR="101600" marT="63500" marB="63500" anchor="ctr">
@@ -11352,14 +11352,14 @@
                         <a:buNone/>
                       </a:pPr>
                       <a:r>
-                        <a:rPr lang="en-US" sz="1500" dirty="0">
+                        <a:rPr lang="en-US" sz="1600" dirty="0">
                           <a:solidFill>
                             <a:schemeClr val="tx1"/>
                           </a:solidFill>
                         </a:rPr>
                         <a:t>Favorable MRD−; APL in molecular CR</a:t>
                       </a:r>
-                      <a:endParaRPr lang="en-US" sz="1500" dirty="0"/>
+                      <a:endParaRPr lang="en-US" sz="1600" dirty="0"/>
                     </a:p>
                   </a:txBody>
                   <a:tcPr marL="25400" marR="101600" marT="63500" marB="63500" anchor="ctr">
@@ -11392,14 +11392,14 @@
                         <a:buNone/>
                       </a:pPr>
                       <a:r>
-                        <a:rPr lang="en-US" sz="1500" dirty="0">
+                        <a:rPr lang="en-US" sz="1600" dirty="0">
                           <a:solidFill>
                             <a:schemeClr val="tx1"/>
                           </a:solidFill>
                         </a:rPr>
                         <a:t>CBF, NPM1, CEBPA bZIP; APL; ML-DS</a:t>
                       </a:r>
-                      <a:endParaRPr lang="en-US" sz="1500" dirty="0"/>
+                      <a:endParaRPr lang="en-US" sz="1600" dirty="0"/>
                     </a:p>
                   </a:txBody>
                   <a:tcPr marL="25400" marR="101600" marT="63500" marB="63500" anchor="ctr">
@@ -11434,14 +11434,14 @@
                         <a:buNone/>
                       </a:pPr>
                       <a:r>
-                        <a:rPr lang="en-US" sz="1500" dirty="0">
+                        <a:rPr lang="en-US" sz="1600" dirty="0">
                           <a:solidFill>
                             <a:schemeClr val="tx1"/>
                           </a:solidFill>
                         </a:rPr>
                         <a:t>Conditioning</a:t>
                       </a:r>
-                      <a:endParaRPr lang="en-US" sz="1500" dirty="0"/>
+                      <a:endParaRPr lang="en-US" sz="1600" dirty="0"/>
                     </a:p>
                   </a:txBody>
                   <a:tcPr marL="25400" marR="101600" marT="63500" marB="63500" anchor="ctr">
@@ -11474,14 +11474,14 @@
                         <a:buNone/>
                       </a:pPr>
                       <a:r>
-                        <a:rPr lang="en-US" sz="1500" dirty="0">
+                        <a:rPr lang="en-US" sz="1600" dirty="0">
                           <a:solidFill>
                             <a:schemeClr val="tx1"/>
                           </a:solidFill>
                         </a:rPr>
                         <a:t>MAC if &lt; 50 y (refractory); RIC otherwise</a:t>
                       </a:r>
-                      <a:endParaRPr lang="en-US" sz="1500" dirty="0"/>
+                      <a:endParaRPr lang="en-US" sz="1600" dirty="0"/>
                     </a:p>
                   </a:txBody>
                   <a:tcPr marL="25400" marR="101600" marT="63500" marB="63500" anchor="ctr">
@@ -11514,14 +11514,14 @@
                         <a:buNone/>
                       </a:pPr>
                       <a:r>
-                        <a:rPr lang="en-US" sz="1500" dirty="0">
+                        <a:rPr lang="en-US" sz="1600" dirty="0">
                           <a:solidFill>
                             <a:schemeClr val="tx1"/>
                           </a:solidFill>
                         </a:rPr>
                         <a:t>MAC, TBI-free; BU/CY with BU drug monitoring</a:t>
                       </a:r>
-                      <a:endParaRPr lang="en-US" sz="1500" dirty="0"/>
+                      <a:endParaRPr lang="en-US" sz="1600" dirty="0"/>
                     </a:p>
                   </a:txBody>
                   <a:tcPr marL="25400" marR="101600" marT="63500" marB="63500" anchor="ctr">
@@ -11556,14 +11556,14 @@
                         <a:buNone/>
                       </a:pPr>
                       <a:r>
-                        <a:rPr lang="en-US" sz="1500" dirty="0">
+                        <a:rPr lang="en-US" sz="1600" dirty="0">
                           <a:solidFill>
                             <a:schemeClr val="tx1"/>
                           </a:solidFill>
                         </a:rPr>
                         <a:t>Donor and source</a:t>
                       </a:r>
-                      <a:endParaRPr lang="en-US" sz="1500" dirty="0"/>
+                      <a:endParaRPr lang="en-US" sz="1600" dirty="0"/>
                     </a:p>
                   </a:txBody>
                   <a:tcPr marL="25400" marR="101600" marT="63500" marB="63500" anchor="ctr">
@@ -11596,14 +11596,14 @@
                         <a:buNone/>
                       </a:pPr>
                       <a:r>
-                        <a:rPr lang="en-US" sz="1500" dirty="0">
+                        <a:rPr lang="en-US" sz="1600" dirty="0">
                           <a:solidFill>
                             <a:schemeClr val="tx1"/>
                           </a:solidFill>
                         </a:rPr>
                         <a:t>Mostly unrelated or haplo; mostly PBSC</a:t>
                       </a:r>
-                      <a:endParaRPr lang="en-US" sz="1500" dirty="0"/>
+                      <a:endParaRPr lang="en-US" sz="1600" dirty="0"/>
                     </a:p>
                   </a:txBody>
                   <a:tcPr marL="25400" marR="101600" marT="63500" marB="63500" anchor="ctr">
@@ -11636,14 +11636,14 @@
                         <a:buNone/>
                       </a:pPr>
                       <a:r>
-                        <a:rPr lang="en-US" sz="1500" dirty="0">
+                        <a:rPr lang="en-US" sz="1600" dirty="0">
                           <a:solidFill>
                             <a:schemeClr val="tx1"/>
                           </a:solidFill>
                         </a:rPr>
                         <a:t>MFD or MUD; bone marrow preferred</a:t>
                       </a:r>
-                      <a:endParaRPr lang="en-US" sz="1500" dirty="0"/>
+                      <a:endParaRPr lang="en-US" sz="1600" dirty="0"/>
                     </a:p>
                   </a:txBody>
                   <a:tcPr marL="25400" marR="101600" marT="63500" marB="63500" anchor="ctr">
@@ -11678,14 +11678,14 @@
                         <a:buNone/>
                       </a:pPr>
                       <a:r>
-                        <a:rPr lang="en-US" sz="1500" dirty="0">
+                        <a:rPr lang="en-US" sz="1600" dirty="0">
                           <a:solidFill>
                             <a:schemeClr val="tx1"/>
                           </a:solidFill>
                         </a:rPr>
                         <a:t>TRM</a:t>
                       </a:r>
-                      <a:endParaRPr lang="en-US" sz="1500" dirty="0"/>
+                      <a:endParaRPr lang="en-US" sz="1600" dirty="0"/>
                     </a:p>
                   </a:txBody>
                   <a:tcPr marL="25400" marR="101600" marT="63500" marB="63500" anchor="ctr">
@@ -11718,14 +11718,14 @@
                         <a:buNone/>
                       </a:pPr>
                       <a:r>
-                        <a:rPr lang="en-US" sz="1500" dirty="0">
+                        <a:rPr lang="en-US" sz="1600" dirty="0">
                           <a:solidFill>
                             <a:schemeClr val="tx1"/>
                           </a:solidFill>
                         </a:rPr>
                         <a:t>Estimate with HCT-CI or EBMT score</a:t>
                       </a:r>
-                      <a:endParaRPr lang="en-US" sz="1500" dirty="0"/>
+                      <a:endParaRPr lang="en-US" sz="1600" dirty="0"/>
                     </a:p>
                   </a:txBody>
                   <a:tcPr marL="25400" marR="101600" marT="63500" marB="63500" anchor="ctr">
@@ -11758,14 +11758,14 @@
                         <a:buNone/>
                       </a:pPr>
                       <a:r>
-                        <a:rPr lang="en-US" sz="1500" dirty="0">
+                        <a:rPr lang="en-US" sz="1600" dirty="0">
                           <a:solidFill>
                             <a:schemeClr val="tx1"/>
                           </a:solidFill>
                         </a:rPr>
                         <a:t>Below 10% achievable in CR1</a:t>
                       </a:r>
-                      <a:endParaRPr lang="en-US" sz="1500" dirty="0"/>
+                      <a:endParaRPr lang="en-US" sz="1600" dirty="0"/>
                     </a:p>
                   </a:txBody>
                   <a:tcPr marL="25400" marR="101600" marT="63500" marB="63500" anchor="ctr">
@@ -11800,14 +11800,14 @@
                         <a:buNone/>
                       </a:pPr>
                       <a:r>
-                        <a:rPr lang="en-US" sz="1500" dirty="0">
+                        <a:rPr lang="en-US" sz="1600" dirty="0">
                           <a:solidFill>
                             <a:schemeClr val="tx1"/>
                           </a:solidFill>
                         </a:rPr>
                         <a:t>Relapse</a:t>
                       </a:r>
-                      <a:endParaRPr lang="en-US" sz="1500" dirty="0"/>
+                      <a:endParaRPr lang="en-US" sz="1600" dirty="0"/>
                     </a:p>
                   </a:txBody>
                   <a:tcPr marL="25400" marR="101600" marT="63500" marB="63500" anchor="ctr">
@@ -11840,14 +11840,14 @@
                         <a:buNone/>
                       </a:pPr>
                       <a:r>
-                        <a:rPr lang="en-US" sz="1500" dirty="0">
+                        <a:rPr lang="en-US" sz="1600" dirty="0">
                           <a:solidFill>
                             <a:schemeClr val="tx1"/>
                           </a:solidFill>
                         </a:rPr>
                         <a:t>Main cause of failure after HCT</a:t>
                       </a:r>
-                      <a:endParaRPr lang="en-US" sz="1500" dirty="0"/>
+                      <a:endParaRPr lang="en-US" sz="1600" dirty="0"/>
                     </a:p>
                   </a:txBody>
                   <a:tcPr marL="25400" marR="101600" marT="63500" marB="63500" anchor="ctr">
@@ -11880,14 +11880,14 @@
                         <a:buNone/>
                       </a:pPr>
                       <a:r>
-                        <a:rPr lang="en-US" sz="1500" dirty="0">
+                        <a:rPr lang="en-US" sz="1600" dirty="0">
                           <a:solidFill>
                             <a:schemeClr val="tx1"/>
                           </a:solidFill>
                         </a:rPr>
                         <a:t>CR2 then HCT; second HCT TRM &gt; 30%</a:t>
                       </a:r>
-                      <a:endParaRPr lang="en-US" sz="1500" dirty="0"/>
+                      <a:endParaRPr lang="en-US" sz="1600" dirty="0"/>
                     </a:p>
                   </a:txBody>
                   <a:tcPr marL="25400" marR="101600" marT="63500" marB="63500" anchor="ctr">
@@ -11924,7 +11924,7 @@
         </p:nvSpPr>
         <p:spPr>
           <a:xfrm>
-            <a:off x="685800" y="4663440"/>
+            <a:off x="685800" y="5029200"/>
             <a:ext cx="10817352" cy="411480"/>
           </a:xfrm>
           <a:prstGeom prst="rect">
@@ -18199,7 +18199,7 @@
         </p:nvSpPr>
         <p:spPr>
           <a:xfrm>
-            <a:off x="685800" y="4480560"/>
+            <a:off x="685800" y="4709160"/>
             <a:ext cx="10817352" cy="411480"/>
           </a:xfrm>
           <a:prstGeom prst="rect">
@@ -23115,7 +23115,7 @@
         </p:nvSpPr>
         <p:spPr>
           <a:xfrm>
-            <a:off x="685800" y="4572000"/>
+            <a:off x="685800" y="4754880"/>
             <a:ext cx="10817352" cy="411480"/>
           </a:xfrm>
           <a:prstGeom prst="rect">

</xml_diff>

<commit_message>
Slides: session 27 myeloma and plasma cell disorders; others in progress
Co-Authored-By: Claude Opus 5.5 <noreply@anthropic.com>
Claude-Session: https://claude.ai/code/session_01XkzKv8pUGMF9AsqSCMpnBq
</commit_message>
<xml_diff>
--- a/slides/decks/s21-aml.pptx
+++ b/slides/decks/s21-aml.pptx
@@ -135,13 +135,13 @@
   <p:extLst>
     <p:ext uri="{521415D9-36F7-43E2-AB2F-B90AF26B5E84}">
       <p14:sectionLst xmlns:p14="http://schemas.microsoft.com/office/powerpoint/2010/main">
-        <p14:section name="Opening" id="{42f8e4f0-9ffa-4b3f-173f-451e00e62b3e}">
+        <p14:section name="Opening" id="{df4dd56a-14e6-b40a-20b6-e1729f3945a2}">
           <p14:sldIdLst>
             <p14:sldId id="256"/>
             <p14:sldId id="257"/>
           </p14:sldIdLst>
         </p14:section>
-        <p14:section name="AML in CR1" id="{5c627105-0292-3e71-2d09-73c325bf9099}">
+        <p14:section name="AML in CR1" id="{2add816f-dd89-ae89-dc47-18d2087c68d2}">
           <p14:sldIdLst>
             <p14:sldId id="258"/>
             <p14:sldId id="259"/>
@@ -152,14 +152,14 @@
             <p14:sldId id="264"/>
           </p14:sldIdLst>
         </p14:section>
-        <p14:section name="Advanced AML" id="{72732df7-aaa4-3dd6-f118-f4571ed1b478}">
+        <p14:section name="Advanced AML" id="{754e1183-d165-ff20-b5f3-9de506b2ab54}">
           <p14:sldIdLst>
             <p14:sldId id="265"/>
             <p14:sldId id="266"/>
             <p14:sldId id="267"/>
           </p14:sldIdLst>
         </p14:section>
-        <p14:section name="APL and children" id="{eac0f929-6e99-dfd2-acd2-14b666adeb9d}">
+        <p14:section name="APL and children" id="{c4180590-39fa-4f2f-c72d-4bf1f6833303}">
           <p14:sldIdLst>
             <p14:sldId id="268"/>
             <p14:sldId id="269"/>
@@ -167,7 +167,7 @@
             <p14:sldId id="271"/>
           </p14:sldIdLst>
         </p14:section>
-        <p14:section name="Board questions" id="{8fe274c5-4ccf-5792-e6a8-18a838a4c3ce}">
+        <p14:section name="Board questions" id="{e4825f53-3009-bccc-7db2-0890234daf13}">
           <p14:sldIdLst>
             <p14:sldId id="272"/>
             <p14:sldId id="273"/>
@@ -177,7 +177,7 @@
             <p14:sldId id="277"/>
           </p14:sldIdLst>
         </p14:section>
-        <p14:section name="References" id="{b0760968-ceb4-06ab-5ba2-578c83063e9b}">
+        <p14:section name="References" id="{715553e1-5369-a398-d8f5-cb832afa1858}">
           <p14:sldIdLst>
             <p14:sldId id="278"/>
             <p14:sldId id="279"/>
@@ -185,7 +185,7 @@
             <p14:sldId id="281"/>
           </p14:sldIdLst>
         </p14:section>
-        <p14:section name="Backup" id="{1eee004e-cb3d-113c-933b-f4c73d2c736b}">
+        <p14:section name="Backup" id="{78722025-5cbd-c8e5-0391-1f51a2b30ea7}">
           <p14:sldIdLst>
             <p14:sldId id="282"/>
             <p14:sldId id="283"/>
@@ -11479,7 +11479,7 @@
                             <a:schemeClr val="tx1"/>
                           </a:solidFill>
                         </a:rPr>
-                        <a:t>Refractory AML: MAC if &lt; 50 y; no preferred RIC</a:t>
+                        <a:t>MAC if &lt; 50 y (refractory AML)</a:t>
                       </a:r>
                       <a:endParaRPr lang="en-US" sz="1600" dirty="0"/>
                     </a:p>

</xml_diff>